<commit_message>
Update final project report
</commit_message>
<xml_diff>
--- a/Projet DevOps  Bibliotheque Numerique Microservices.pptx
+++ b/Projet DevOps  Bibliotheque Numerique Microservices.pptx
@@ -285,7 +285,7 @@
           <a:p>
             <a:fld id="{D7FD82F5-31AC-488C-AA74-F470A5E83E0B}" type="datetimeFigureOut">
               <a:rPr lang="fr-FR" smtClean="0"/>
-              <a:t>06/07/2026</a:t>
+              <a:t>12/07/2026</a:t>
             </a:fld>
             <a:endParaRPr lang="fr-FR"/>
           </a:p>
@@ -483,7 +483,7 @@
           <a:p>
             <a:fld id="{D7FD82F5-31AC-488C-AA74-F470A5E83E0B}" type="datetimeFigureOut">
               <a:rPr lang="fr-FR" smtClean="0"/>
-              <a:t>06/07/2026</a:t>
+              <a:t>12/07/2026</a:t>
             </a:fld>
             <a:endParaRPr lang="fr-FR"/>
           </a:p>
@@ -691,7 +691,7 @@
           <a:p>
             <a:fld id="{D7FD82F5-31AC-488C-AA74-F470A5E83E0B}" type="datetimeFigureOut">
               <a:rPr lang="fr-FR" smtClean="0"/>
-              <a:t>06/07/2026</a:t>
+              <a:t>12/07/2026</a:t>
             </a:fld>
             <a:endParaRPr lang="fr-FR"/>
           </a:p>
@@ -889,7 +889,7 @@
           <a:p>
             <a:fld id="{D7FD82F5-31AC-488C-AA74-F470A5E83E0B}" type="datetimeFigureOut">
               <a:rPr lang="fr-FR" smtClean="0"/>
-              <a:t>06/07/2026</a:t>
+              <a:t>12/07/2026</a:t>
             </a:fld>
             <a:endParaRPr lang="fr-FR"/>
           </a:p>
@@ -1087,7 +1087,7 @@
           <a:p>
             <a:fld id="{D7FD82F5-31AC-488C-AA74-F470A5E83E0B}" type="datetimeFigureOut">
               <a:rPr lang="fr-FR" smtClean="0"/>
-              <a:t>06/07/2026</a:t>
+              <a:t>12/07/2026</a:t>
             </a:fld>
             <a:endParaRPr lang="fr-FR"/>
           </a:p>
@@ -1362,7 +1362,7 @@
           <a:p>
             <a:fld id="{D7FD82F5-31AC-488C-AA74-F470A5E83E0B}" type="datetimeFigureOut">
               <a:rPr lang="fr-FR" smtClean="0"/>
-              <a:t>06/07/2026</a:t>
+              <a:t>12/07/2026</a:t>
             </a:fld>
             <a:endParaRPr lang="fr-FR"/>
           </a:p>
@@ -1627,7 +1627,7 @@
           <a:p>
             <a:fld id="{D7FD82F5-31AC-488C-AA74-F470A5E83E0B}" type="datetimeFigureOut">
               <a:rPr lang="fr-FR" smtClean="0"/>
-              <a:t>06/07/2026</a:t>
+              <a:t>12/07/2026</a:t>
             </a:fld>
             <a:endParaRPr lang="fr-FR"/>
           </a:p>
@@ -2039,7 +2039,7 @@
           <a:p>
             <a:fld id="{D7FD82F5-31AC-488C-AA74-F470A5E83E0B}" type="datetimeFigureOut">
               <a:rPr lang="fr-FR" smtClean="0"/>
-              <a:t>06/07/2026</a:t>
+              <a:t>12/07/2026</a:t>
             </a:fld>
             <a:endParaRPr lang="fr-FR"/>
           </a:p>
@@ -2180,7 +2180,7 @@
           <a:p>
             <a:fld id="{D7FD82F5-31AC-488C-AA74-F470A5E83E0B}" type="datetimeFigureOut">
               <a:rPr lang="fr-FR" smtClean="0"/>
-              <a:t>06/07/2026</a:t>
+              <a:t>12/07/2026</a:t>
             </a:fld>
             <a:endParaRPr lang="fr-FR"/>
           </a:p>
@@ -2293,7 +2293,7 @@
           <a:p>
             <a:fld id="{D7FD82F5-31AC-488C-AA74-F470A5E83E0B}" type="datetimeFigureOut">
               <a:rPr lang="fr-FR" smtClean="0"/>
-              <a:t>06/07/2026</a:t>
+              <a:t>12/07/2026</a:t>
             </a:fld>
             <a:endParaRPr lang="fr-FR"/>
           </a:p>
@@ -2604,7 +2604,7 @@
           <a:p>
             <a:fld id="{D7FD82F5-31AC-488C-AA74-F470A5E83E0B}" type="datetimeFigureOut">
               <a:rPr lang="fr-FR" smtClean="0"/>
-              <a:t>06/07/2026</a:t>
+              <a:t>12/07/2026</a:t>
             </a:fld>
             <a:endParaRPr lang="fr-FR"/>
           </a:p>
@@ -2892,7 +2892,7 @@
           <a:p>
             <a:fld id="{D7FD82F5-31AC-488C-AA74-F470A5E83E0B}" type="datetimeFigureOut">
               <a:rPr lang="fr-FR" smtClean="0"/>
-              <a:t>06/07/2026</a:t>
+              <a:t>12/07/2026</a:t>
             </a:fld>
             <a:endParaRPr lang="fr-FR"/>
           </a:p>
@@ -3133,7 +3133,7 @@
           <a:p>
             <a:fld id="{D7FD82F5-31AC-488C-AA74-F470A5E83E0B}" type="datetimeFigureOut">
               <a:rPr lang="fr-FR" smtClean="0"/>
-              <a:t>06/07/2026</a:t>
+              <a:t>12/07/2026</a:t>
             </a:fld>
             <a:endParaRPr lang="fr-FR"/>
           </a:p>
@@ -3809,7 +3809,7 @@
                 </a:solidFill>
                 <a:latin typeface="Calibri"/>
               </a:rPr>
-              <a:t>1. Prénom NOM</a:t>
+              <a:t>1. Ibrahima FAYE</a:t>
             </a:r>
           </a:p>
         </p:txBody>
@@ -3867,13 +3867,13 @@
           <a:p>
             <a:pPr algn="l"/>
             <a:r>
-              <a:rPr lang="fr-FR" sz="1500">
+              <a:rPr lang="fr-FR" sz="1500" dirty="0">
                 <a:solidFill>
                   <a:srgbClr val="FFFFFF"/>
                 </a:solidFill>
                 <a:latin typeface="Calibri"/>
               </a:rPr>
-              <a:t>2. Prénom NOM</a:t>
+              <a:t>2. Mamadou NIANG</a:t>
             </a:r>
           </a:p>
         </p:txBody>
@@ -3931,13 +3931,31 @@
           <a:p>
             <a:pPr algn="l"/>
             <a:r>
-              <a:rPr lang="fr-FR" sz="1500">
+              <a:rPr lang="fr-FR" sz="1500" dirty="0">
                 <a:solidFill>
                   <a:srgbClr val="FFFFFF"/>
                 </a:solidFill>
                 <a:latin typeface="Calibri"/>
               </a:rPr>
-              <a:t>3. Prénom NOM</a:t>
+              <a:t>3. Aicha </a:t>
+            </a:r>
+            <a:r>
+              <a:rPr lang="fr-FR" sz="1500" dirty="0" err="1">
+                <a:solidFill>
+                  <a:srgbClr val="FFFFFF"/>
+                </a:solidFill>
+                <a:latin typeface="Calibri"/>
+              </a:rPr>
+              <a:t>Codou</a:t>
+            </a:r>
+            <a:r>
+              <a:rPr lang="fr-FR" sz="1500" dirty="0">
+                <a:solidFill>
+                  <a:srgbClr val="FFFFFF"/>
+                </a:solidFill>
+                <a:latin typeface="Calibri"/>
+              </a:rPr>
+              <a:t> Arab LY</a:t>
             </a:r>
           </a:p>
         </p:txBody>
@@ -3993,16 +4011,45 @@
           </a:bodyPr>
           <a:lstStyle/>
           <a:p>
-            <a:pPr algn="l"/>
-            <a:r>
-              <a:rPr lang="fr-FR" sz="1500">
+            <a:r>
+              <a:rPr lang="fr-FR" sz="1500" dirty="0">
                 <a:solidFill>
                   <a:srgbClr val="FFFFFF"/>
                 </a:solidFill>
                 <a:latin typeface="Calibri"/>
               </a:rPr>
-              <a:t>4. Prénom NOM</a:t>
-            </a:r>
+              <a:t>4. </a:t>
+            </a:r>
+            <a:r>
+              <a:rPr lang="fr-FR" sz="1500" dirty="0">
+                <a:solidFill>
+                  <a:srgbClr val="FFFFFF"/>
+                </a:solidFill>
+              </a:rPr>
+              <a:t>Mame Diarra </a:t>
+            </a:r>
+            <a:r>
+              <a:rPr lang="fr-FR" sz="1500" dirty="0" err="1">
+                <a:solidFill>
+                  <a:srgbClr val="FFFFFF"/>
+                </a:solidFill>
+              </a:rPr>
+              <a:t>Nguassali</a:t>
+            </a:r>
+            <a:r>
+              <a:rPr lang="fr-FR" sz="1500" dirty="0">
+                <a:solidFill>
+                  <a:srgbClr val="FFFFFF"/>
+                </a:solidFill>
+              </a:rPr>
+              <a:t> DIENG</a:t>
+            </a:r>
+            <a:endParaRPr lang="fr-FR" sz="1500" dirty="0">
+              <a:solidFill>
+                <a:srgbClr val="FFFFFF"/>
+              </a:solidFill>
+              <a:latin typeface="Calibri"/>
+            </a:endParaRPr>
           </a:p>
         </p:txBody>
       </p:sp>
@@ -4059,13 +4106,13 @@
           <a:p>
             <a:pPr algn="l"/>
             <a:r>
-              <a:rPr lang="fr-FR" sz="1500">
+              <a:rPr lang="fr-FR" sz="1500" dirty="0">
                 <a:solidFill>
                   <a:srgbClr val="FFFFFF"/>
                 </a:solidFill>
                 <a:latin typeface="Calibri"/>
               </a:rPr>
-              <a:t>5. Prénom NOM</a:t>
+              <a:t>5. Cheikh Ahmadou Bamba FALL</a:t>
             </a:r>
           </a:p>
         </p:txBody>
@@ -4123,13 +4170,56 @@
           <a:p>
             <a:pPr algn="l"/>
             <a:r>
-              <a:rPr lang="fr-FR" sz="1500">
+              <a:rPr lang="fr-FR" sz="1500" dirty="0">
                 <a:solidFill>
                   <a:srgbClr val="FFFFFF"/>
                 </a:solidFill>
                 <a:latin typeface="Calibri"/>
               </a:rPr>
-              <a:t>6. Prénom NOM</a:t>
+              <a:t>6. Alioune DIOP</a:t>
+            </a:r>
+          </a:p>
+        </p:txBody>
+      </p:sp>
+      <p:sp>
+        <p:nvSpPr>
+          <p:cNvPr id="5" name="TextBox 4">
+            <a:extLst>
+              <a:ext uri="{FF2B5EF4-FFF2-40B4-BE49-F238E27FC236}">
+                <a16:creationId xmlns:a16="http://schemas.microsoft.com/office/drawing/2014/main" id="{71881313-0325-45C8-D832-F26BE86D31E5}"/>
+              </a:ext>
+            </a:extLst>
+          </p:cNvPr>
+          <p:cNvSpPr txBox="1"/>
+          <p:nvPr/>
+        </p:nvSpPr>
+        <p:spPr>
+          <a:xfrm>
+            <a:off x="-243840" y="6185035"/>
+            <a:ext cx="9204959" cy="646331"/>
+          </a:xfrm>
+          <a:prstGeom prst="rect">
+            <a:avLst/>
+          </a:prstGeom>
+          <a:noFill/>
+        </p:spPr>
+        <p:txBody>
+          <a:bodyPr wrap="square">
+            <a:spAutoFit/>
+          </a:bodyPr>
+          <a:lstStyle/>
+          <a:p>
+            <a:pPr algn="ctr"/>
+            <a:r>
+              <a:rPr lang="en-GB" dirty="0"/>
+              <a:t>Lien GitHub :</a:t>
+            </a:r>
+          </a:p>
+          <a:p>
+            <a:pPr algn="ctr"/>
+            <a:r>
+              <a:rPr lang="en-GB" u="sng" dirty="0"/>
+              <a:t>https://github.com/WAF-DIT/bibliotheque-microservices</a:t>
             </a:r>
           </a:p>
         </p:txBody>

</xml_diff>